<commit_message>
Audience slide 1: headline trimmed
</commit_message>
<xml_diff>
--- a/board-audience-2026-10-22/LLA_Audience_Board.pptx
+++ b/board-audience-2026-10-22/LLA_Audience_Board.pptx
@@ -3091,14 +3091,14 @@
       <p:grpSpPr/>
       <p:pic>
         <p:nvPicPr>
-          <p:cNvPr id="2" name="Picture 1" descr="hi1.png"/>
+          <p:cNvPr id="2" name="Picture 1" descr="slide-1.png"/>
           <p:cNvPicPr>
             <a:picLocks noChangeAspect="1"/>
           </p:cNvPicPr>
           <p:nvPr/>
         </p:nvPicPr>
         <p:blipFill>
-          <a:blip r:embed="rId2"/>
+          <a:blip r:embed="rId3"/>
           <a:stretch>
             <a:fillRect/>
           </a:stretch>

</xml_diff>